<commit_message>
fix(presentation): embed universal high-res PNGs instead of raw SVGs to fix cross-platform red X rendering error
</commit_message>
<xml_diff>
--- a/PMB_Architecture_Pitch.pptx
+++ b/PMB_Architecture_Pitch.pptx
@@ -2300,20 +2300,14 @@
       </p:sp>
       <p:pic>
         <p:nvPicPr>
-          <p:cNvPr id="18" name="Image 0" descr="d:\persistant_message_broker\docs\slide1_topology.svg">    </p:cNvPr>
+          <p:cNvPr id="18" name="Image 0" descr="d:\persistant_message_broker\docs\slide1_topology.png">    </p:cNvPr>
           <p:cNvPicPr>
             <a:picLocks noChangeAspect="1"/>
           </p:cNvPicPr>
           <p:nvPr/>
         </p:nvPicPr>
         <p:blipFill>
-          <a:blip r:embed="rId1">
-            <a:extLst>
-              <a:ext uri="{96DAC541-7B7A-43D3-8B79-37D633B846F1}">
-                <asvg:svgBlip xmlns:asvg="http://schemas.microsoft.com/office/drawing/2016/SVG/main" r:embed="rId2"/>
-              </a:ext>
-            </a:extLst>
-          </a:blip>
+          <a:blip r:embed="rId1"/>
           <a:stretch>
             <a:fillRect/>
           </a:stretch>
@@ -4134,20 +4128,14 @@
       </p:sp>
       <p:pic>
         <p:nvPicPr>
-          <p:cNvPr id="10" name="Image 0" descr="d:\persistant_message_broker\docs\slide2_problem.svg">    </p:cNvPr>
+          <p:cNvPr id="10" name="Image 0" descr="d:\persistant_message_broker\docs\slide2_problem.png">    </p:cNvPr>
           <p:cNvPicPr>
             <a:picLocks noChangeAspect="1"/>
           </p:cNvPicPr>
           <p:nvPr/>
         </p:nvPicPr>
         <p:blipFill>
-          <a:blip r:embed="rId1">
-            <a:extLst>
-              <a:ext uri="{96DAC541-7B7A-43D3-8B79-37D633B846F1}">
-                <asvg:svgBlip xmlns:asvg="http://schemas.microsoft.com/office/drawing/2016/SVG/main" r:embed="rId2"/>
-              </a:ext>
-            </a:extLst>
-          </a:blip>
+          <a:blip r:embed="rId1"/>
           <a:stretch>
             <a:fillRect/>
           </a:stretch>
@@ -4708,20 +4696,14 @@
       </p:sp>
       <p:pic>
         <p:nvPicPr>
-          <p:cNvPr id="8" name="Image 0" descr="d:\persistant_message_broker\docs\slide3_solution.svg">    </p:cNvPr>
+          <p:cNvPr id="8" name="Image 0" descr="d:\persistant_message_broker\docs\slide3_solution.png">    </p:cNvPr>
           <p:cNvPicPr>
             <a:picLocks noChangeAspect="1"/>
           </p:cNvPicPr>
           <p:nvPr/>
         </p:nvPicPr>
         <p:blipFill>
-          <a:blip r:embed="rId1">
-            <a:extLst>
-              <a:ext uri="{96DAC541-7B7A-43D3-8B79-37D633B846F1}">
-                <asvg:svgBlip xmlns:asvg="http://schemas.microsoft.com/office/drawing/2016/SVG/main" r:embed="rId2"/>
-              </a:ext>
-            </a:extLst>
-          </a:blip>
+          <a:blip r:embed="rId1"/>
           <a:stretch>
             <a:fillRect/>
           </a:stretch>
@@ -5727,20 +5709,14 @@
       </p:sp>
       <p:pic>
         <p:nvPicPr>
-          <p:cNvPr id="8" name="Image 0" descr="d:\persistant_message_broker\docs\slide4_atomic_stack.svg">    </p:cNvPr>
+          <p:cNvPr id="8" name="Image 0" descr="d:\persistant_message_broker\docs\slide4_atomic_stack.png">    </p:cNvPr>
           <p:cNvPicPr>
             <a:picLocks noChangeAspect="1"/>
           </p:cNvPicPr>
           <p:nvPr/>
         </p:nvPicPr>
         <p:blipFill>
-          <a:blip r:embed="rId1">
-            <a:extLst>
-              <a:ext uri="{96DAC541-7B7A-43D3-8B79-37D633B846F1}">
-                <asvg:svgBlip xmlns:asvg="http://schemas.microsoft.com/office/drawing/2016/SVG/main" r:embed="rId2"/>
-              </a:ext>
-            </a:extLst>
-          </a:blip>
+          <a:blip r:embed="rId1"/>
           <a:stretch>
             <a:fillRect/>
           </a:stretch>
@@ -6301,20 +6277,14 @@
       </p:sp>
       <p:pic>
         <p:nvPicPr>
-          <p:cNvPr id="8" name="Image 0" descr="d:\persistant_message_broker\docs\slide5_group_commit.svg">    </p:cNvPr>
+          <p:cNvPr id="8" name="Image 0" descr="d:\persistant_message_broker\docs\slide5_group_commit.png">    </p:cNvPr>
           <p:cNvPicPr>
             <a:picLocks noChangeAspect="1"/>
           </p:cNvPicPr>
           <p:nvPr/>
         </p:nvPicPr>
         <p:blipFill>
-          <a:blip r:embed="rId1">
-            <a:extLst>
-              <a:ext uri="{96DAC541-7B7A-43D3-8B79-37D633B846F1}">
-                <asvg:svgBlip xmlns:asvg="http://schemas.microsoft.com/office/drawing/2016/SVG/main" r:embed="rId2"/>
-              </a:ext>
-            </a:extLst>
-          </a:blip>
+          <a:blip r:embed="rId1"/>
           <a:stretch>
             <a:fillRect/>
           </a:stretch>
@@ -6875,20 +6845,14 @@
       </p:sp>
       <p:pic>
         <p:nvPicPr>
-          <p:cNvPr id="8" name="Image 0" descr="d:\persistant_message_broker\docs\slide6_router_delivery.svg">    </p:cNvPr>
+          <p:cNvPr id="8" name="Image 0" descr="d:\persistant_message_broker\docs\slide6_router_delivery.png">    </p:cNvPr>
           <p:cNvPicPr>
             <a:picLocks noChangeAspect="1"/>
           </p:cNvPicPr>
           <p:nvPr/>
         </p:nvPicPr>
         <p:blipFill>
-          <a:blip r:embed="rId1">
-            <a:extLst>
-              <a:ext uri="{96DAC541-7B7A-43D3-8B79-37D633B846F1}">
-                <asvg:svgBlip xmlns:asvg="http://schemas.microsoft.com/office/drawing/2016/SVG/main" r:embed="rId2"/>
-              </a:ext>
-            </a:extLst>
-          </a:blip>
+          <a:blip r:embed="rId1"/>
           <a:stretch>
             <a:fillRect/>
           </a:stretch>
@@ -7449,20 +7413,14 @@
       </p:sp>
       <p:pic>
         <p:nvPicPr>
-          <p:cNvPr id="8" name="Image 0" descr="d:\persistant_message_broker\docs\slide7_compaction.svg">    </p:cNvPr>
+          <p:cNvPr id="8" name="Image 0" descr="d:\persistant_message_broker\docs\slide7_compaction.png">    </p:cNvPr>
           <p:cNvPicPr>
             <a:picLocks noChangeAspect="1"/>
           </p:cNvPicPr>
           <p:nvPr/>
         </p:nvPicPr>
         <p:blipFill>
-          <a:blip r:embed="rId1">
-            <a:extLst>
-              <a:ext uri="{96DAC541-7B7A-43D3-8B79-37D633B846F1}">
-                <asvg:svgBlip xmlns:asvg="http://schemas.microsoft.com/office/drawing/2016/SVG/main" r:embed="rId2"/>
-              </a:ext>
-            </a:extLst>
-          </a:blip>
+          <a:blip r:embed="rId1"/>
           <a:stretch>
             <a:fillRect/>
           </a:stretch>
@@ -8023,20 +7981,14 @@
       </p:sp>
       <p:pic>
         <p:nvPicPr>
-          <p:cNvPr id="8" name="Image 0" descr="d:\persistant_message_broker\docs\slide8_wire_protocol.svg">    </p:cNvPr>
+          <p:cNvPr id="8" name="Image 0" descr="d:\persistant_message_broker\docs\slide8_wire_protocol.png">    </p:cNvPr>
           <p:cNvPicPr>
             <a:picLocks noChangeAspect="1"/>
           </p:cNvPicPr>
           <p:nvPr/>
         </p:nvPicPr>
         <p:blipFill>
-          <a:blip r:embed="rId1">
-            <a:extLst>
-              <a:ext uri="{96DAC541-7B7A-43D3-8B79-37D633B846F1}">
-                <asvg:svgBlip xmlns:asvg="http://schemas.microsoft.com/office/drawing/2016/SVG/main" r:embed="rId2"/>
-              </a:ext>
-            </a:extLst>
-          </a:blip>
+          <a:blip r:embed="rId1"/>
           <a:stretch>
             <a:fillRect/>
           </a:stretch>

</xml_diff>